<commit_message>
Refresh Planora docs and handle assistant network timeouts
</commit_message>
<xml_diff>
--- a/assets/Planora_Overview_2026.pptx
+++ b/assets/Planora_Overview_2026.pptx
@@ -2,18 +2,18 @@
 <file path=ppt/presentation.xml><?xml version="1.0" encoding="utf-8"?>
 <p:presentation xmlns:p="http://schemas.openxmlformats.org/presentationml/2006/main">
   <p:sldMasterIdLst>
-    <p:sldMasterId xmlns:r="http://schemas.openxmlformats.org/officeDocument/2006/relationships" id="2147483648" r:id="Rc7b7216c346c4e4e"/>
+    <p:sldMasterId xmlns:r="http://schemas.openxmlformats.org/officeDocument/2006/relationships" id="2147483648" r:id="R71652f49878f4cb9"/>
   </p:sldMasterIdLst>
   <p:notesMasterIdLst>
-    <p:notesMasterId xmlns:r="http://schemas.openxmlformats.org/officeDocument/2006/relationships" r:id="Racf499b823de4b46"/>
+    <p:notesMasterId xmlns:r="http://schemas.openxmlformats.org/officeDocument/2006/relationships" r:id="R753a46d628964934"/>
   </p:notesMasterIdLst>
   <p:sldIdLst>
-    <p:sldId xmlns:r="http://schemas.openxmlformats.org/officeDocument/2006/relationships" id="256" r:id="Re4435805e9b543c1"/>
-    <p:sldId xmlns:r="http://schemas.openxmlformats.org/officeDocument/2006/relationships" id="257" r:id="R070fe0aa02dc425c"/>
-    <p:sldId xmlns:r="http://schemas.openxmlformats.org/officeDocument/2006/relationships" id="258" r:id="Rb77bb2391b844148"/>
-    <p:sldId xmlns:r="http://schemas.openxmlformats.org/officeDocument/2006/relationships" id="259" r:id="R5bea7e02eda24f22"/>
-    <p:sldId xmlns:r="http://schemas.openxmlformats.org/officeDocument/2006/relationships" id="260" r:id="Rdab221a483d147e0"/>
-    <p:sldId xmlns:r="http://schemas.openxmlformats.org/officeDocument/2006/relationships" id="261" r:id="R381c64ba8483452d"/>
+    <p:sldId xmlns:r="http://schemas.openxmlformats.org/officeDocument/2006/relationships" id="256" r:id="R605bdf7e80f74dac"/>
+    <p:sldId xmlns:r="http://schemas.openxmlformats.org/officeDocument/2006/relationships" id="257" r:id="Re27fb831ee134bc0"/>
+    <p:sldId xmlns:r="http://schemas.openxmlformats.org/officeDocument/2006/relationships" id="258" r:id="Rd43d60ac93a845dc"/>
+    <p:sldId xmlns:r="http://schemas.openxmlformats.org/officeDocument/2006/relationships" id="259" r:id="Ra9ff4a64bf5344a9"/>
+    <p:sldId xmlns:r="http://schemas.openxmlformats.org/officeDocument/2006/relationships" id="260" r:id="Rcff1b2bb45dc47ff"/>
+    <p:sldId xmlns:r="http://schemas.openxmlformats.org/officeDocument/2006/relationships" id="261" r:id="Ra3333fab72d440bd"/>
   </p:sldIdLst>
   <p:sldSz cx="12192000" cy="6858000"/>
   <p:notesSz cx="6858000" cy="9144000"/>
@@ -865,7 +865,7 @@
   </p:cSld>
   <p:clrMap bg1="lt1" tx1="dk1" bg2="lt2" tx2="dk2" accent1="accent1" accent2="accent2" accent3="accent3" accent4="accent4" accent5="accent5" accent6="accent6" hlink="hlink" folHlink="folHlink"/>
   <p:sldLayoutIdLst>
-    <p:sldLayoutId xmlns:r="http://schemas.openxmlformats.org/officeDocument/2006/relationships" id="2147483649" r:id="R8b1654f552204da3"/>
+    <p:sldLayoutId xmlns:r="http://schemas.openxmlformats.org/officeDocument/2006/relationships" id="2147483649" r:id="R214e353cbfd647fc"/>
   </p:sldLayoutIdLst>
   <p:txStyles>
     <p:titleStyle>
@@ -1445,6 +1445,7 @@
           <a:lstStyle xmlns:a="http://schemas.openxmlformats.org/drawingml/2006/main"/>
           <a:p xmlns:a="http://schemas.openxmlformats.org/drawingml/2006/main">
             <a:pPr>
+              <a:buNone/>
               <a:defRPr sz="1275" b="1">
                 <a:solidFill>
                   <a:srgbClr val="A4C5FF"/>
@@ -1502,6 +1503,7 @@
           <a:lstStyle xmlns:a="http://schemas.openxmlformats.org/drawingml/2006/main"/>
           <a:p xmlns:a="http://schemas.openxmlformats.org/drawingml/2006/main">
             <a:pPr>
+              <a:buNone/>
               <a:defRPr sz="3525" b="1">
                 <a:solidFill>
                   <a:srgbClr val="F4F7FF"/>
@@ -1559,6 +1561,7 @@
           <a:lstStyle xmlns:a="http://schemas.openxmlformats.org/drawingml/2006/main"/>
           <a:p xmlns:a="http://schemas.openxmlformats.org/drawingml/2006/main">
             <a:pPr>
+              <a:buNone/>
               <a:defRPr sz="2625" b="1">
                 <a:solidFill>
                   <a:srgbClr val="A4C5FF"/>
@@ -1616,6 +1619,7 @@
           <a:lstStyle xmlns:a="http://schemas.openxmlformats.org/drawingml/2006/main"/>
           <a:p xmlns:a="http://schemas.openxmlformats.org/drawingml/2006/main">
             <a:pPr>
+              <a:buNone/>
               <a:defRPr sz="2025" b="0">
                 <a:solidFill>
                   <a:srgbClr val="F4F7FF"/>
@@ -1673,6 +1677,7 @@
           <a:lstStyle xmlns:a="http://schemas.openxmlformats.org/drawingml/2006/main"/>
           <a:p xmlns:a="http://schemas.openxmlformats.org/drawingml/2006/main">
             <a:pPr>
+              <a:buNone/>
               <a:defRPr sz="1800" b="1">
                 <a:solidFill>
                   <a:srgbClr val="A4C5FF"/>
@@ -1730,6 +1735,7 @@
           <a:lstStyle xmlns:a="http://schemas.openxmlformats.org/drawingml/2006/main"/>
           <a:p xmlns:a="http://schemas.openxmlformats.org/drawingml/2006/main">
             <a:pPr>
+              <a:buNone/>
               <a:defRPr sz="1050" b="0">
                 <a:solidFill>
                   <a:srgbClr val="B6C5DF"/>
@@ -1787,6 +1793,7 @@
           <a:lstStyle xmlns:a="http://schemas.openxmlformats.org/drawingml/2006/main"/>
           <a:p xmlns:a="http://schemas.openxmlformats.org/drawingml/2006/main">
             <a:pPr>
+              <a:buNone/>
               <a:defRPr sz="1200" b="1">
                 <a:solidFill>
                   <a:srgbClr val="A4C5FF"/>
@@ -1873,6 +1880,7 @@
           <a:lstStyle xmlns:a="http://schemas.openxmlformats.org/drawingml/2006/main"/>
           <a:p xmlns:a="http://schemas.openxmlformats.org/drawingml/2006/main">
             <a:pPr>
+              <a:buNone/>
               <a:defRPr sz="1275" b="1">
                 <a:solidFill>
                   <a:srgbClr val="A4C5FF"/>
@@ -1930,6 +1938,7 @@
           <a:lstStyle xmlns:a="http://schemas.openxmlformats.org/drawingml/2006/main"/>
           <a:p xmlns:a="http://schemas.openxmlformats.org/drawingml/2006/main">
             <a:pPr>
+              <a:buNone/>
               <a:defRPr sz="3525" b="1">
                 <a:solidFill>
                   <a:srgbClr val="F4F7FF"/>
@@ -1955,14 +1964,14 @@
       </p:sp>
       <p:pic>
         <p:nvPicPr>
-          <p:cNvPr id="9" name=""/>
+          <p:cNvPr id="11" name=""/>
           <p:cNvPicPr>
             <a:picLocks xmlns:a="http://schemas.openxmlformats.org/drawingml/2006/main" noChangeAspect="1"/>
           </p:cNvPicPr>
           <p:nvPr/>
         </p:nvPicPr>
         <p:blipFill>
-          <a:blip xmlns:r="http://schemas.openxmlformats.org/officeDocument/2006/relationships" xmlns:a="http://schemas.openxmlformats.org/drawingml/2006/main" r:embed="Rcf786dc373a04c6a"/>
+          <a:blip xmlns:r="http://schemas.openxmlformats.org/officeDocument/2006/relationships" xmlns:a="http://schemas.openxmlformats.org/drawingml/2006/main" r:embed="Rdda24b508c50409e"/>
           <a:stretch xmlns:a="http://schemas.openxmlformats.org/drawingml/2006/main"/>
         </p:blipFill>
         <p:spPr>
@@ -2009,6 +2018,7 @@
           <a:lstStyle xmlns:a="http://schemas.openxmlformats.org/drawingml/2006/main"/>
           <a:p xmlns:a="http://schemas.openxmlformats.org/drawingml/2006/main">
             <a:pPr>
+              <a:buNone/>
               <a:defRPr sz="1350" b="0">
                 <a:solidFill>
                   <a:srgbClr val="A4C5FF"/>
@@ -2027,7 +2037,7 @@
                 <a:ea typeface="Bitstream Charter"/>
                 <a:cs typeface="Bitstream Charter"/>
               </a:rPr>
-              <a:t>Years 1–4  ·  IT, Data Science &amp; AI, Software  ·  Cyber Security (courses pending)</a:t>
+              <a:t>Years 1–4  ·  IT (Years 2–4), Data Science &amp; AI, Software  ·  Cyber Security (courses pending)</a:t>
             </a:r>
           </a:p>
         </p:txBody>
@@ -2066,6 +2076,7 @@
           <a:lstStyle xmlns:a="http://schemas.openxmlformats.org/drawingml/2006/main"/>
           <a:p xmlns:a="http://schemas.openxmlformats.org/drawingml/2006/main">
             <a:pPr>
+              <a:buNone/>
               <a:defRPr sz="1050" b="0">
                 <a:solidFill>
                   <a:srgbClr val="B6C5DF"/>
@@ -2123,6 +2134,7 @@
           <a:lstStyle xmlns:a="http://schemas.openxmlformats.org/drawingml/2006/main"/>
           <a:p xmlns:a="http://schemas.openxmlformats.org/drawingml/2006/main">
             <a:pPr>
+              <a:buNone/>
               <a:defRPr sz="1200" b="1">
                 <a:solidFill>
                   <a:srgbClr val="A4C5FF"/>
@@ -2209,6 +2221,7 @@
           <a:lstStyle xmlns:a="http://schemas.openxmlformats.org/drawingml/2006/main"/>
           <a:p xmlns:a="http://schemas.openxmlformats.org/drawingml/2006/main">
             <a:pPr>
+              <a:buNone/>
               <a:defRPr sz="1275" b="1">
                 <a:solidFill>
                   <a:srgbClr val="A4C5FF"/>
@@ -2266,6 +2279,7 @@
           <a:lstStyle xmlns:a="http://schemas.openxmlformats.org/drawingml/2006/main"/>
           <a:p xmlns:a="http://schemas.openxmlformats.org/drawingml/2006/main">
             <a:pPr>
+              <a:buNone/>
               <a:defRPr sz="3525" b="1">
                 <a:solidFill>
                   <a:srgbClr val="F4F7FF"/>
@@ -2323,6 +2337,7 @@
           <a:lstStyle xmlns:a="http://schemas.openxmlformats.org/drawingml/2006/main"/>
           <a:p xmlns:a="http://schemas.openxmlformats.org/drawingml/2006/main">
             <a:pPr>
+              <a:buNone/>
               <a:defRPr sz="2250" b="0">
                 <a:solidFill>
                   <a:srgbClr val="F4F7FF"/>
@@ -2351,6 +2366,7 @@
           </a:p>
           <a:p xmlns:a="http://schemas.openxmlformats.org/drawingml/2006/main">
             <a:pPr>
+              <a:buNone/>
               <a:defRPr sz="2250" b="0">
                 <a:solidFill>
                   <a:srgbClr val="F4F7FF"/>
@@ -2379,6 +2395,7 @@
           </a:p>
           <a:p xmlns:a="http://schemas.openxmlformats.org/drawingml/2006/main">
             <a:pPr>
+              <a:buNone/>
               <a:defRPr sz="2250" b="0">
                 <a:solidFill>
                   <a:srgbClr val="F4F7FF"/>
@@ -2436,6 +2453,7 @@
           <a:lstStyle xmlns:a="http://schemas.openxmlformats.org/drawingml/2006/main"/>
           <a:p xmlns:a="http://schemas.openxmlformats.org/drawingml/2006/main">
             <a:pPr>
+              <a:buNone/>
               <a:defRPr sz="1725" b="0">
                 <a:solidFill>
                   <a:srgbClr val="A4C5FF"/>
@@ -2493,6 +2511,7 @@
           <a:lstStyle xmlns:a="http://schemas.openxmlformats.org/drawingml/2006/main"/>
           <a:p xmlns:a="http://schemas.openxmlformats.org/drawingml/2006/main">
             <a:pPr>
+              <a:buNone/>
               <a:defRPr sz="1050" b="0">
                 <a:solidFill>
                   <a:srgbClr val="B6C5DF"/>
@@ -2550,6 +2569,7 @@
           <a:lstStyle xmlns:a="http://schemas.openxmlformats.org/drawingml/2006/main"/>
           <a:p xmlns:a="http://schemas.openxmlformats.org/drawingml/2006/main">
             <a:pPr>
+              <a:buNone/>
               <a:defRPr sz="1200" b="1">
                 <a:solidFill>
                   <a:srgbClr val="A4C5FF"/>
@@ -2636,6 +2656,7 @@
           <a:lstStyle xmlns:a="http://schemas.openxmlformats.org/drawingml/2006/main"/>
           <a:p xmlns:a="http://schemas.openxmlformats.org/drawingml/2006/main">
             <a:pPr>
+              <a:buNone/>
               <a:defRPr sz="1275" b="1">
                 <a:solidFill>
                   <a:srgbClr val="A4C5FF"/>
@@ -2693,6 +2714,7 @@
           <a:lstStyle xmlns:a="http://schemas.openxmlformats.org/drawingml/2006/main"/>
           <a:p xmlns:a="http://schemas.openxmlformats.org/drawingml/2006/main">
             <a:pPr>
+              <a:buNone/>
               <a:defRPr sz="3525" b="1">
                 <a:solidFill>
                   <a:srgbClr val="F4F7FF"/>
@@ -2750,6 +2772,7 @@
           <a:lstStyle xmlns:a="http://schemas.openxmlformats.org/drawingml/2006/main"/>
           <a:p xmlns:a="http://schemas.openxmlformats.org/drawingml/2006/main">
             <a:pPr>
+              <a:buNone/>
               <a:defRPr sz="2175" b="0">
                 <a:solidFill>
                   <a:srgbClr val="F4F7FF"/>
@@ -2773,6 +2796,7 @@
           </a:p>
           <a:p xmlns:a="http://schemas.openxmlformats.org/drawingml/2006/main">
             <a:pPr>
+              <a:buNone/>
               <a:defRPr sz="2175" b="0">
                 <a:solidFill>
                   <a:srgbClr val="F4F7FF"/>
@@ -2796,6 +2820,7 @@
           </a:p>
           <a:p xmlns:a="http://schemas.openxmlformats.org/drawingml/2006/main">
             <a:pPr>
+              <a:buNone/>
               <a:defRPr sz="2175" b="0">
                 <a:solidFill>
                   <a:srgbClr val="F4F7FF"/>
@@ -2819,6 +2844,7 @@
           </a:p>
           <a:p xmlns:a="http://schemas.openxmlformats.org/drawingml/2006/main">
             <a:pPr>
+              <a:buNone/>
               <a:defRPr sz="2175" b="0">
                 <a:solidFill>
                   <a:srgbClr val="F4F7FF"/>
@@ -2876,6 +2902,7 @@
           <a:lstStyle xmlns:a="http://schemas.openxmlformats.org/drawingml/2006/main"/>
           <a:p xmlns:a="http://schemas.openxmlformats.org/drawingml/2006/main">
             <a:pPr>
+              <a:buNone/>
               <a:defRPr sz="1725" b="1">
                 <a:solidFill>
                   <a:srgbClr val="A4C5FF"/>
@@ -2933,6 +2960,7 @@
           <a:lstStyle xmlns:a="http://schemas.openxmlformats.org/drawingml/2006/main"/>
           <a:p xmlns:a="http://schemas.openxmlformats.org/drawingml/2006/main">
             <a:pPr>
+              <a:buNone/>
               <a:defRPr sz="1050" b="0">
                 <a:solidFill>
                   <a:srgbClr val="B6C5DF"/>
@@ -2990,6 +3018,7 @@
           <a:lstStyle xmlns:a="http://schemas.openxmlformats.org/drawingml/2006/main"/>
           <a:p xmlns:a="http://schemas.openxmlformats.org/drawingml/2006/main">
             <a:pPr>
+              <a:buNone/>
               <a:defRPr sz="1200" b="1">
                 <a:solidFill>
                   <a:srgbClr val="A4C5FF"/>
@@ -3076,6 +3105,7 @@
           <a:lstStyle xmlns:a="http://schemas.openxmlformats.org/drawingml/2006/main"/>
           <a:p xmlns:a="http://schemas.openxmlformats.org/drawingml/2006/main">
             <a:pPr>
+              <a:buNone/>
               <a:defRPr sz="1275" b="1">
                 <a:solidFill>
                   <a:srgbClr val="A4C5FF"/>
@@ -3133,6 +3163,7 @@
           <a:lstStyle xmlns:a="http://schemas.openxmlformats.org/drawingml/2006/main"/>
           <a:p xmlns:a="http://schemas.openxmlformats.org/drawingml/2006/main">
             <a:pPr>
+              <a:buNone/>
               <a:defRPr sz="3525" b="1">
                 <a:solidFill>
                   <a:srgbClr val="F4F7FF"/>
@@ -3190,6 +3221,7 @@
           <a:lstStyle xmlns:a="http://schemas.openxmlformats.org/drawingml/2006/main"/>
           <a:p xmlns:a="http://schemas.openxmlformats.org/drawingml/2006/main">
             <a:pPr>
+              <a:buNone/>
               <a:defRPr sz="2175" b="0">
                 <a:solidFill>
                   <a:srgbClr val="F4F7FF"/>
@@ -3213,6 +3245,7 @@
           </a:p>
           <a:p xmlns:a="http://schemas.openxmlformats.org/drawingml/2006/main">
             <a:pPr>
+              <a:buNone/>
               <a:defRPr sz="2175" b="0">
                 <a:solidFill>
                   <a:srgbClr val="F4F7FF"/>
@@ -3236,6 +3269,7 @@
           </a:p>
           <a:p xmlns:a="http://schemas.openxmlformats.org/drawingml/2006/main">
             <a:pPr>
+              <a:buNone/>
               <a:defRPr sz="2175" b="0">
                 <a:solidFill>
                   <a:srgbClr val="F4F7FF"/>
@@ -3293,6 +3327,7 @@
           <a:lstStyle xmlns:a="http://schemas.openxmlformats.org/drawingml/2006/main"/>
           <a:p xmlns:a="http://schemas.openxmlformats.org/drawingml/2006/main">
             <a:pPr>
+              <a:buNone/>
               <a:defRPr sz="1650" b="0">
                 <a:solidFill>
                   <a:srgbClr val="A4C5FF"/>
@@ -3311,7 +3346,7 @@
                 <a:ea typeface="Bitstream Charter"/>
                 <a:cs typeface="Bitstream Charter"/>
               </a:rPr>
-              <a:t>Private admin workspace: two accounts, saved draft history and feedback ratings. Course data changes require review and a separate release.</a:t>
+              <a:t>Private admin workspace: two accounts, saved drafts and feedback with optional names, ratings and comments. Course data changes require a separate release.</a:t>
             </a:r>
           </a:p>
         </p:txBody>
@@ -3350,6 +3385,7 @@
           <a:lstStyle xmlns:a="http://schemas.openxmlformats.org/drawingml/2006/main"/>
           <a:p xmlns:a="http://schemas.openxmlformats.org/drawingml/2006/main">
             <a:pPr>
+              <a:buNone/>
               <a:defRPr sz="1500" b="0">
                 <a:solidFill>
                   <a:srgbClr val="B6C5DF"/>
@@ -3407,6 +3443,7 @@
           <a:lstStyle xmlns:a="http://schemas.openxmlformats.org/drawingml/2006/main"/>
           <a:p xmlns:a="http://schemas.openxmlformats.org/drawingml/2006/main">
             <a:pPr>
+              <a:buNone/>
               <a:defRPr sz="1050" b="0">
                 <a:solidFill>
                   <a:srgbClr val="B6C5DF"/>
@@ -3464,6 +3501,7 @@
           <a:lstStyle xmlns:a="http://schemas.openxmlformats.org/drawingml/2006/main"/>
           <a:p xmlns:a="http://schemas.openxmlformats.org/drawingml/2006/main">
             <a:pPr>
+              <a:buNone/>
               <a:defRPr sz="1200" b="1">
                 <a:solidFill>
                   <a:srgbClr val="A4C5FF"/>
@@ -3550,6 +3588,7 @@
           <a:lstStyle xmlns:a="http://schemas.openxmlformats.org/drawingml/2006/main"/>
           <a:p xmlns:a="http://schemas.openxmlformats.org/drawingml/2006/main">
             <a:pPr>
+              <a:buNone/>
               <a:defRPr sz="1275" b="1">
                 <a:solidFill>
                   <a:srgbClr val="A4C5FF"/>
@@ -3607,6 +3646,7 @@
           <a:lstStyle xmlns:a="http://schemas.openxmlformats.org/drawingml/2006/main"/>
           <a:p xmlns:a="http://schemas.openxmlformats.org/drawingml/2006/main">
             <a:pPr>
+              <a:buNone/>
               <a:defRPr sz="3525" b="1">
                 <a:solidFill>
                   <a:srgbClr val="F4F7FF"/>
@@ -3664,6 +3704,7 @@
           <a:lstStyle xmlns:a="http://schemas.openxmlformats.org/drawingml/2006/main"/>
           <a:p xmlns:a="http://schemas.openxmlformats.org/drawingml/2006/main">
             <a:pPr>
+              <a:buNone/>
               <a:defRPr sz="2025" b="0">
                 <a:solidFill>
                   <a:srgbClr val="F4F7FF"/>
@@ -3687,6 +3728,7 @@
           </a:p>
           <a:p xmlns:a="http://schemas.openxmlformats.org/drawingml/2006/main">
             <a:pPr>
+              <a:buNone/>
               <a:defRPr sz="2025" b="0">
                 <a:solidFill>
                   <a:srgbClr val="F4F7FF"/>
@@ -3710,6 +3752,7 @@
           </a:p>
           <a:p xmlns:a="http://schemas.openxmlformats.org/drawingml/2006/main">
             <a:pPr>
+              <a:buNone/>
               <a:defRPr sz="2025" b="0">
                 <a:solidFill>
                   <a:srgbClr val="F4F7FF"/>
@@ -3767,6 +3810,7 @@
           <a:lstStyle xmlns:a="http://schemas.openxmlformats.org/drawingml/2006/main"/>
           <a:p xmlns:a="http://schemas.openxmlformats.org/drawingml/2006/main">
             <a:pPr>
+              <a:buNone/>
               <a:defRPr sz="1725" b="0">
                 <a:solidFill>
                   <a:srgbClr val="A4C5FF"/>
@@ -3824,6 +3868,7 @@
           <a:lstStyle xmlns:a="http://schemas.openxmlformats.org/drawingml/2006/main"/>
           <a:p xmlns:a="http://schemas.openxmlformats.org/drawingml/2006/main">
             <a:pPr>
+              <a:buNone/>
               <a:defRPr sz="1050" b="0">
                 <a:solidFill>
                   <a:srgbClr val="B6C5DF"/>
@@ -3881,6 +3926,7 @@
           <a:lstStyle xmlns:a="http://schemas.openxmlformats.org/drawingml/2006/main"/>
           <a:p xmlns:a="http://schemas.openxmlformats.org/drawingml/2006/main">
             <a:pPr>
+              <a:buNone/>
               <a:defRPr sz="1200" b="1">
                 <a:solidFill>
                   <a:srgbClr val="A4C5FF"/>

</xml_diff>